<commit_message>
Team change: two-person credits (Kurosawa, Fukuo) across deck, video, README and submission drafts
Co-Authored-By: Claude Fable 5.1 <noreply@anthropic.com>
</commit_message>
<xml_diff>
--- a/docs/pitch_deck.pptx
+++ b/docs/pitch_deck.pptx
@@ -119,46 +119,46 @@
   <p:extLst>
     <p:ext uri="{521415D9-36F7-43E2-AB2F-B90AF26B5E84}">
       <p14:sectionLst xmlns:p14="http://schemas.microsoft.com/office/powerpoint/2010/main">
-        <p14:section name="Title" id="{35e4875d-c133-1fd1-b867-17e042bb83fc}">
+        <p14:section name="Title" id="{f8617127-c09c-d697-b523-26551c30298c}">
           <p14:sldIdLst>
             <p14:sldId id="256"/>
           </p14:sldIdLst>
         </p14:section>
-        <p14:section name="Executive summary" id="{aedb1556-a479-42cc-bd8a-879be017bae5}">
+        <p14:section name="Executive summary" id="{cb2a38f4-9e7e-3536-24f1-34ddda1b0d37}">
           <p14:sldIdLst>
             <p14:sldId id="257"/>
           </p14:sldIdLst>
         </p14:section>
-        <p14:section name="1. The problem" id="{4742dd28-6d31-e2aa-1735-9eb24c3f47cb}">
+        <p14:section name="1. The problem" id="{63435f5a-bf54-3eed-73f1-126b4ff23c71}">
           <p14:sldIdLst>
             <p14:sldId id="258"/>
             <p14:sldId id="259"/>
           </p14:sldIdLst>
         </p14:section>
-        <p14:section name="2. The solution" id="{85529c54-909f-e6e8-6e66-2f40090da4d5}">
+        <p14:section name="2. The solution" id="{8169fbef-1b54-4022-a0ee-e9d193759b4c}">
           <p14:sldIdLst>
             <p14:sldId id="260"/>
             <p14:sldId id="261"/>
           </p14:sldIdLst>
         </p14:section>
-        <p14:section name="3. The product" id="{4200a3f3-9d30-24b0-c6aa-a5b483a1957f}">
+        <p14:section name="3. The product" id="{f183bfdc-cfbe-65b5-68cc-2cda2118bef0}">
           <p14:sldIdLst>
             <p14:sldId id="262"/>
           </p14:sldIdLst>
         </p14:section>
-        <p14:section name="4. Technical merit" id="{8d8781d6-aab7-9549-89a6-a7565f8fe3f6}">
+        <p14:section name="4. Technical merit" id="{6008083e-d98a-873a-e23c-4a9bc2221a71}">
           <p14:sldIdLst>
             <p14:sldId id="263"/>
             <p14:sldId id="264"/>
           </p14:sldIdLst>
         </p14:section>
-        <p14:section name="5. Impact and innovation" id="{c876bd25-820e-8e9a-bbac-ecc433329a3e}">
+        <p14:section name="5. Impact and innovation" id="{48c42808-d760-42a2-e9a1-15ca18e98af6}">
           <p14:sldIdLst>
             <p14:sldId id="265"/>
             <p14:sldId id="266"/>
           </p14:sldIdLst>
         </p14:section>
-        <p14:section name="6. Roadmap and team" id="{1da69330-f62a-1a3e-57b4-19f36fd71e61}">
+        <p14:section name="6. Roadmap and team" id="{738a50dd-873c-f796-948d-f89edda71c33}">
           <p14:sldIdLst>
             <p14:sldId id="267"/>
             <p14:sldId id="268"/>
@@ -2635,7 +2635,7 @@
                   <a:srgbClr val="3C4049"/>
                 </a:solidFill>
               </a:rPr>
-              <a:t>Kakeru Kurosawa · Junichi Fujioka · Kotaro Fukuo</a:t>
+              <a:t>Kakeru Kurosawa · Kotaro Fukuo</a:t>
             </a:r>
             <a:endParaRPr lang="en-US" sz="1600" dirty="0"/>
           </a:p>
@@ -3687,7 +3687,7 @@
                   <a:schemeClr val="tx1"/>
                 </a:solidFill>
               </a:rPr>
-              <a:t>Cost figures are illustrative assumptions for a mid-size plant; the team's manufacturing CFO is validating them against industry benchmarks for the final pitch.</a:t>
+              <a:t>Cost figures are illustrative assumptions for a mid-size plant, to be replaced with a customer plant's own downtime cost and incident counts in the four-week pilot.</a:t>
             </a:r>
             <a:endParaRPr lang="en-US" sz="1000" dirty="0"/>
           </a:p>
@@ -5264,7 +5264,7 @@
         <p:spPr>
           <a:xfrm>
             <a:off x="502920" y="5257800"/>
-            <a:ext cx="3605784" cy="1051560"/>
+            <a:ext cx="5500116" cy="1051560"/>
           </a:xfrm>
           <a:prstGeom prst="roundRect">
             <a:avLst>
@@ -5291,7 +5291,7 @@
         <p:spPr>
           <a:xfrm>
             <a:off x="640080" y="5303520"/>
-            <a:ext cx="3331464" cy="987552"/>
+            <a:ext cx="5225796" cy="987552"/>
           </a:xfrm>
           <a:prstGeom prst="rect">
             <a:avLst/>
@@ -5326,7 +5326,7 @@
                   <a:schemeClr val="accent1"/>
                 </a:solidFill>
               </a:rPr>
-              <a:t>Product &amp; engineering lead</a:t>
+              <a:t>Product, domain &amp; engineering lead</a:t>
             </a:r>
             <a:endParaRPr lang="en-US" sz="1200" dirty="0"/>
           </a:p>
@@ -5340,7 +5340,7 @@
                   <a:schemeClr val="tx1"/>
                 </a:solidFill>
               </a:rPr>
-              <a:t>Built the agent, the graph pipeline and the web app. COO at AIdeaLab; previously PwC consulting and new-business development for edge AI at Sony.</a:t>
+              <a:t>Built the ontology, the agent, the graph pipeline and the web app. COO at AIdeaLab; previously PwC consulting and new-business development for edge AI at Sony, working with manufacturing customers.</a:t>
             </a:r>
             <a:endParaRPr lang="en-US" sz="1200" dirty="0"/>
           </a:p>
@@ -5354,8 +5354,8 @@
         </p:nvSpPr>
         <p:spPr>
           <a:xfrm>
-            <a:off x="4291584" y="5257800"/>
-            <a:ext cx="3605784" cy="1051560"/>
+            <a:off x="6185916" y="5257800"/>
+            <a:ext cx="5500116" cy="1051560"/>
           </a:xfrm>
           <a:prstGeom prst="roundRect">
             <a:avLst>
@@ -5381,8 +5381,8 @@
         </p:nvSpPr>
         <p:spPr>
           <a:xfrm>
-            <a:off x="4428744" y="5303520"/>
-            <a:ext cx="3331464" cy="987552"/>
+            <a:off x="6323076" y="5303520"/>
+            <a:ext cx="5225796" cy="987552"/>
           </a:xfrm>
           <a:prstGeom prst="rect">
             <a:avLst/>
@@ -5403,7 +5403,7 @@
                   <a:schemeClr val="tx1"/>
                 </a:solidFill>
               </a:rPr>
-              <a:t>Junichi Fujioka</a:t>
+              <a:t>Kotaro Fukuo</a:t>
             </a:r>
             <a:endParaRPr lang="en-US" sz="1200" dirty="0"/>
           </a:p>
@@ -5417,7 +5417,7 @@
                   <a:schemeClr val="accent1"/>
                 </a:solidFill>
               </a:rPr>
-              <a:t>Manufacturing &amp; impact</a:t>
+              <a:t>Software engineering</a:t>
             </a:r>
             <a:endParaRPr lang="en-US" sz="1200" dirty="0"/>
           </a:p>
@@ -5431,98 +5431,7 @@
                   <a:schemeClr val="tx1"/>
                 </a:solidFill>
               </a:rPr>
-              <a:t>Manufacturing CFO. About 30 years in a global electronics group across plants, finance and operations. Validates the problem and quantifies the value.</a:t>
-            </a:r>
-            <a:endParaRPr lang="en-US" sz="1200" dirty="0"/>
-          </a:p>
-        </p:txBody>
-      </p:sp>
-      <p:sp>
-        <p:nvSpPr>
-          <p:cNvPr id="27" name="Shape 25"/>
-          <p:cNvSpPr/>
-          <p:nvPr/>
-        </p:nvSpPr>
-        <p:spPr>
-          <a:xfrm>
-            <a:off x="8080248" y="5257800"/>
-            <a:ext cx="3605784" cy="1051560"/>
-          </a:xfrm>
-          <a:prstGeom prst="roundRect">
-            <a:avLst>
-              <a:gd name="adj" fmla="val 6957"/>
-            </a:avLst>
-          </a:prstGeom>
-          <a:solidFill>
-            <a:schemeClr val="bg2"/>
-          </a:solidFill>
-          <a:ln w="12700">
-            <a:solidFill>
-              <a:schemeClr val="bg2"/>
-            </a:solidFill>
-            <a:prstDash val="solid"/>
-          </a:ln>
-        </p:spPr>
-      </p:sp>
-      <p:sp>
-        <p:nvSpPr>
-          <p:cNvPr id="28" name="Text 26"/>
-          <p:cNvSpPr txBox="1"/>
-          <p:nvPr/>
-        </p:nvSpPr>
-        <p:spPr>
-          <a:xfrm>
-            <a:off x="8217408" y="5303520"/>
-            <a:ext cx="3331464" cy="987552"/>
-          </a:xfrm>
-          <a:prstGeom prst="rect">
-            <a:avLst/>
-          </a:prstGeom>
-          <a:noFill/>
-          <a:ln/>
-        </p:spPr>
-        <p:txBody>
-          <a:bodyPr wrap="square" lIns="0" tIns="0" rIns="0" bIns="0" rtlCol="0" anchor="t"/>
-          <a:lstStyle/>
-          <a:p>
-            <a:pPr indent="0" marL="0">
-              <a:buNone/>
-            </a:pPr>
-            <a:r>
-              <a:rPr lang="en-US" sz="1200" b="1" dirty="0">
-                <a:solidFill>
-                  <a:schemeClr val="tx1"/>
-                </a:solidFill>
-              </a:rPr>
-              <a:t>Kotaro Fukuo</a:t>
-            </a:r>
-            <a:endParaRPr lang="en-US" sz="1200" dirty="0"/>
-          </a:p>
-          <a:p>
-            <a:pPr indent="0" marL="0">
-              <a:buNone/>
-            </a:pPr>
-            <a:r>
-              <a:rPr lang="en-US" sz="1000" b="1" dirty="0">
-                <a:solidFill>
-                  <a:schemeClr val="accent1"/>
-                </a:solidFill>
-              </a:rPr>
-              <a:t>Software engineering</a:t>
-            </a:r>
-            <a:endParaRPr lang="en-US" sz="1200" dirty="0"/>
-          </a:p>
-          <a:p>
-            <a:pPr indent="0" marL="0">
-              <a:buNone/>
-            </a:pPr>
-            <a:r>
-              <a:rPr lang="en-US" sz="900" dirty="0">
-                <a:solidFill>
-                  <a:schemeClr val="tx1"/>
-                </a:solidFill>
-              </a:rPr>
-              <a:t>Software engineer with 8+ years in mobile and backend (React Native, TypeScript, Ruby on Rails, AWS). B.E. Mechanical Engineering Informatics, Meiji University.</a:t>
+              <a:t>Software engineer with 8+ years in mobile and backend (React Native, TypeScript, Ruby on Rails, AWS); owns the field-facing mobile UI on the roadmap. B.E. Mechanical Engineering Informatics, Meiji University.</a:t>
             </a:r>
             <a:endParaRPr lang="en-US" sz="1200" dirty="0"/>
           </a:p>
@@ -5702,7 +5611,7 @@
                   <a:srgbClr val="DCE4FE"/>
                 </a:solidFill>
               </a:rPr>
-              <a:t>Kakeru Kurosawa · Junichi Fujioka · Kotaro Fukuo</a:t>
+              <a:t>Kakeru Kurosawa · Kotaro Fukuo</a:t>
             </a:r>
             <a:endParaRPr lang="en-US" sz="1600" dirty="0"/>
           </a:p>

</xml_diff>